<commit_message>
docs: update PPT - Strategic Alignment + ROCm Differentiation + fix data
- New page 2: Strategic Alignment (AMD ROCm strategy + 10x growth)
- New page 10: ROCm Differentiation (open-source, cost, no lock-in)
- Fixed: 105→29.4, 15.4→4.3, 628→264.8 across all slides
- Total: 9 → 11 pages
</commit_message>
<xml_diff>
--- a/docs/CodeRisk_Agent_Presentation.pptx
+++ b/docs/CodeRisk_Agent_Presentation.pptx
@@ -14,6 +14,8 @@
     <p:sldId id="262" r:id="rId13"/>
     <p:sldId id="263" r:id="rId14"/>
     <p:sldId id="264" r:id="rId15"/>
+    <p:sldId id="265" r:id="rId16"/>
+    <p:sldId id="266" r:id="rId17"/>
   </p:sldIdLst>
   <p:sldSz cx="12191695" cy="6858000" type="screen4x3"/>
   <p:notesSz cx="6858000" cy="9144000"/>
@@ -3287,6 +3289,1417 @@
 </p:sld>
 </file>
 
+<file path=ppt/slides/slide10.xml><?xml version="1.0" encoding="utf-8"?>
+<p:sld xmlns:a="http://schemas.openxmlformats.org/drawingml/2006/main" xmlns:p="http://schemas.openxmlformats.org/presentationml/2006/main" xmlns:r="http://schemas.openxmlformats.org/officeDocument/2006/relationships">
+  <p:cSld>
+    <p:bg>
+      <p:bgPr>
+        <a:solidFill>
+          <a:srgbClr val="0D0D0D"/>
+        </a:solidFill>
+        <a:effectLst/>
+      </p:bgPr>
+    </p:bg>
+    <p:spTree>
+      <p:nvGrpSpPr>
+        <p:cNvPr id="1" name=""/>
+        <p:cNvGrpSpPr/>
+        <p:nvPr/>
+      </p:nvGrpSpPr>
+      <p:grpSpPr/>
+      <p:sp>
+        <p:nvSpPr>
+          <p:cNvPr id="2" name="TextBox 1"/>
+          <p:cNvSpPr txBox="1"/>
+          <p:nvPr/>
+        </p:nvSpPr>
+        <p:spPr>
+          <a:xfrm>
+            <a:off x="457200" y="274320"/>
+            <a:ext cx="8229600" cy="731520"/>
+          </a:xfrm>
+          <a:prstGeom prst="rect">
+            <a:avLst/>
+          </a:prstGeom>
+          <a:noFill/>
+        </p:spPr>
+        <p:txBody>
+          <a:bodyPr wrap="none">
+            <a:spAutoFit/>
+          </a:bodyPr>
+          <a:lstStyle/>
+          <a:p>
+            <a:pPr algn="ctr">
+              <a:defRPr sz="2800" b="1">
+                <a:solidFill>
+                  <a:srgbClr val="ED1C24"/>
+                </a:solidFill>
+              </a:defRPr>
+            </a:pPr>
+            <a:r>
+              <a:t>Strategic Alignment — Why CodeRisk Matters to AMD</a:t>
+            </a:r>
+          </a:p>
+        </p:txBody>
+      </p:sp>
+      <p:sp>
+        <p:nvSpPr>
+          <p:cNvPr id="3" name="Rectangle 2"/>
+          <p:cNvSpPr/>
+          <p:nvPr/>
+        </p:nvSpPr>
+        <p:spPr>
+          <a:xfrm>
+            <a:off x="365760" y="1280160"/>
+            <a:ext cx="1920240" cy="2560320"/>
+          </a:xfrm>
+          <a:prstGeom prst="rect">
+            <a:avLst/>
+          </a:prstGeom>
+          <a:solidFill>
+            <a:srgbClr val="1A1A1A"/>
+          </a:solidFill>
+          <a:ln>
+            <a:noFill/>
+          </a:ln>
+        </p:spPr>
+        <p:style>
+          <a:lnRef idx="1">
+            <a:schemeClr val="accent1"/>
+          </a:lnRef>
+          <a:fillRef idx="3">
+            <a:schemeClr val="accent1"/>
+          </a:fillRef>
+          <a:effectRef idx="2">
+            <a:schemeClr val="accent1"/>
+          </a:effectRef>
+          <a:fontRef idx="minor">
+            <a:schemeClr val="lt1"/>
+          </a:fontRef>
+        </p:style>
+        <p:txBody>
+          <a:bodyPr rtlCol="0" anchor="ctr"/>
+          <a:lstStyle/>
+          <a:p>
+            <a:pPr algn="ctr"/>
+          </a:p>
+        </p:txBody>
+      </p:sp>
+      <p:sp>
+        <p:nvSpPr>
+          <p:cNvPr id="4" name="Rectangle 3"/>
+          <p:cNvSpPr/>
+          <p:nvPr/>
+        </p:nvSpPr>
+        <p:spPr>
+          <a:xfrm>
+            <a:off x="365760" y="1280160"/>
+            <a:ext cx="1920240" cy="45720"/>
+          </a:xfrm>
+          <a:prstGeom prst="rect">
+            <a:avLst/>
+          </a:prstGeom>
+          <a:solidFill>
+            <a:srgbClr val="ED1C24"/>
+          </a:solidFill>
+          <a:ln>
+            <a:noFill/>
+          </a:ln>
+        </p:spPr>
+        <p:style>
+          <a:lnRef idx="1">
+            <a:schemeClr val="accent1"/>
+          </a:lnRef>
+          <a:fillRef idx="3">
+            <a:schemeClr val="accent1"/>
+          </a:fillRef>
+          <a:effectRef idx="2">
+            <a:schemeClr val="accent1"/>
+          </a:effectRef>
+          <a:fontRef idx="minor">
+            <a:schemeClr val="lt1"/>
+          </a:fontRef>
+        </p:style>
+        <p:txBody>
+          <a:bodyPr rtlCol="0" anchor="ctr"/>
+          <a:lstStyle/>
+          <a:p>
+            <a:pPr algn="ctr"/>
+          </a:p>
+        </p:txBody>
+      </p:sp>
+      <p:sp>
+        <p:nvSpPr>
+          <p:cNvPr id="5" name="TextBox 4"/>
+          <p:cNvSpPr txBox="1"/>
+          <p:nvPr/>
+        </p:nvSpPr>
+        <p:spPr>
+          <a:xfrm>
+            <a:off x="502920" y="1417320"/>
+            <a:ext cx="1645920" cy="457200"/>
+          </a:xfrm>
+          <a:prstGeom prst="rect">
+            <a:avLst/>
+          </a:prstGeom>
+          <a:noFill/>
+        </p:spPr>
+        <p:txBody>
+          <a:bodyPr wrap="none">
+            <a:spAutoFit/>
+          </a:bodyPr>
+          <a:lstStyle/>
+          <a:p>
+            <a:pPr>
+              <a:defRPr sz="2800"/>
+            </a:pPr>
+            <a:r>
+              <a:t>🎯</a:t>
+            </a:r>
+          </a:p>
+        </p:txBody>
+      </p:sp>
+      <p:sp>
+        <p:nvSpPr>
+          <p:cNvPr id="6" name="TextBox 5"/>
+          <p:cNvSpPr txBox="1"/>
+          <p:nvPr/>
+        </p:nvSpPr>
+        <p:spPr>
+          <a:xfrm>
+            <a:off x="502920" y="1828800"/>
+            <a:ext cx="1645920" cy="548640"/>
+          </a:xfrm>
+          <a:prstGeom prst="rect">
+            <a:avLst/>
+          </a:prstGeom>
+          <a:noFill/>
+        </p:spPr>
+        <p:txBody>
+          <a:bodyPr wrap="square">
+            <a:spAutoFit/>
+          </a:bodyPr>
+          <a:lstStyle/>
+          <a:p>
+            <a:pPr>
+              <a:defRPr sz="1200" b="1">
+                <a:solidFill>
+                  <a:srgbClr val="FFFFFF"/>
+                </a:solidFill>
+              </a:defRPr>
+            </a:pPr>
+            <a:r>
+              <a:t>ROCm is AMD's #1 Strategic Priority</a:t>
+            </a:r>
+          </a:p>
+        </p:txBody>
+      </p:sp>
+      <p:sp>
+        <p:nvSpPr>
+          <p:cNvPr id="7" name="TextBox 6"/>
+          <p:cNvSpPr txBox="1"/>
+          <p:nvPr/>
+        </p:nvSpPr>
+        <p:spPr>
+          <a:xfrm>
+            <a:off x="502920" y="2377440"/>
+            <a:ext cx="1645920" cy="1371600"/>
+          </a:xfrm>
+          <a:prstGeom prst="rect">
+            <a:avLst/>
+          </a:prstGeom>
+          <a:noFill/>
+        </p:spPr>
+        <p:txBody>
+          <a:bodyPr wrap="square">
+            <a:spAutoFit/>
+          </a:bodyPr>
+          <a:lstStyle/>
+          <a:p>
+            <a:pPr>
+              <a:defRPr sz="1000">
+                <a:solidFill>
+                  <a:srgbClr val="CCCCCC"/>
+                </a:solidFill>
+              </a:defRPr>
+            </a:pPr>
+            <a:r>
+              <a:t>AMD's Q2 2026 earnings call positioned ROCm as the key competitive advantage against NVIDIA's CUDA. Open strategy to mobilize global developers.</a:t>
+            </a:r>
+          </a:p>
+        </p:txBody>
+      </p:sp>
+      <p:sp>
+        <p:nvSpPr>
+          <p:cNvPr id="8" name="Rectangle 7"/>
+          <p:cNvSpPr/>
+          <p:nvPr/>
+        </p:nvSpPr>
+        <p:spPr>
+          <a:xfrm>
+            <a:off x="2423160" y="1280160"/>
+            <a:ext cx="1920240" cy="2560320"/>
+          </a:xfrm>
+          <a:prstGeom prst="rect">
+            <a:avLst/>
+          </a:prstGeom>
+          <a:solidFill>
+            <a:srgbClr val="1A1A1A"/>
+          </a:solidFill>
+          <a:ln>
+            <a:noFill/>
+          </a:ln>
+        </p:spPr>
+        <p:style>
+          <a:lnRef idx="1">
+            <a:schemeClr val="accent1"/>
+          </a:lnRef>
+          <a:fillRef idx="3">
+            <a:schemeClr val="accent1"/>
+          </a:fillRef>
+          <a:effectRef idx="2">
+            <a:schemeClr val="accent1"/>
+          </a:effectRef>
+          <a:fontRef idx="minor">
+            <a:schemeClr val="lt1"/>
+          </a:fontRef>
+        </p:style>
+        <p:txBody>
+          <a:bodyPr rtlCol="0" anchor="ctr"/>
+          <a:lstStyle/>
+          <a:p>
+            <a:pPr algn="ctr"/>
+          </a:p>
+        </p:txBody>
+      </p:sp>
+      <p:sp>
+        <p:nvSpPr>
+          <p:cNvPr id="9" name="Rectangle 8"/>
+          <p:cNvSpPr/>
+          <p:nvPr/>
+        </p:nvSpPr>
+        <p:spPr>
+          <a:xfrm>
+            <a:off x="2423160" y="1280160"/>
+            <a:ext cx="1920240" cy="45720"/>
+          </a:xfrm>
+          <a:prstGeom prst="rect">
+            <a:avLst/>
+          </a:prstGeom>
+          <a:solidFill>
+            <a:srgbClr val="ED1C24"/>
+          </a:solidFill>
+          <a:ln>
+            <a:noFill/>
+          </a:ln>
+        </p:spPr>
+        <p:style>
+          <a:lnRef idx="1">
+            <a:schemeClr val="accent1"/>
+          </a:lnRef>
+          <a:fillRef idx="3">
+            <a:schemeClr val="accent1"/>
+          </a:fillRef>
+          <a:effectRef idx="2">
+            <a:schemeClr val="accent1"/>
+          </a:effectRef>
+          <a:fontRef idx="minor">
+            <a:schemeClr val="lt1"/>
+          </a:fontRef>
+        </p:style>
+        <p:txBody>
+          <a:bodyPr rtlCol="0" anchor="ctr"/>
+          <a:lstStyle/>
+          <a:p>
+            <a:pPr algn="ctr"/>
+          </a:p>
+        </p:txBody>
+      </p:sp>
+      <p:sp>
+        <p:nvSpPr>
+          <p:cNvPr id="10" name="TextBox 9"/>
+          <p:cNvSpPr txBox="1"/>
+          <p:nvPr/>
+        </p:nvSpPr>
+        <p:spPr>
+          <a:xfrm>
+            <a:off x="2560320" y="1417320"/>
+            <a:ext cx="1645920" cy="457200"/>
+          </a:xfrm>
+          <a:prstGeom prst="rect">
+            <a:avLst/>
+          </a:prstGeom>
+          <a:noFill/>
+        </p:spPr>
+        <p:txBody>
+          <a:bodyPr wrap="none">
+            <a:spAutoFit/>
+          </a:bodyPr>
+          <a:lstStyle/>
+          <a:p>
+            <a:pPr>
+              <a:defRPr sz="2800"/>
+            </a:pPr>
+            <a:r>
+              <a:t>📈</a:t>
+            </a:r>
+          </a:p>
+        </p:txBody>
+      </p:sp>
+      <p:sp>
+        <p:nvSpPr>
+          <p:cNvPr id="11" name="TextBox 10"/>
+          <p:cNvSpPr txBox="1"/>
+          <p:nvPr/>
+        </p:nvSpPr>
+        <p:spPr>
+          <a:xfrm>
+            <a:off x="2560320" y="1828800"/>
+            <a:ext cx="1645920" cy="548640"/>
+          </a:xfrm>
+          <a:prstGeom prst="rect">
+            <a:avLst/>
+          </a:prstGeom>
+          <a:noFill/>
+        </p:spPr>
+        <p:txBody>
+          <a:bodyPr wrap="square">
+            <a:spAutoFit/>
+          </a:bodyPr>
+          <a:lstStyle/>
+          <a:p>
+            <a:pPr>
+              <a:defRPr sz="1200" b="1">
+                <a:solidFill>
+                  <a:srgbClr val="FFFFFF"/>
+                </a:solidFill>
+              </a:defRPr>
+            </a:pPr>
+            <a:r>
+              <a:t>ROCm Community: 10× Growth</a:t>
+            </a:r>
+          </a:p>
+        </p:txBody>
+      </p:sp>
+      <p:sp>
+        <p:nvSpPr>
+          <p:cNvPr id="12" name="TextBox 11"/>
+          <p:cNvSpPr txBox="1"/>
+          <p:nvPr/>
+        </p:nvSpPr>
+        <p:spPr>
+          <a:xfrm>
+            <a:off x="2560320" y="2377440"/>
+            <a:ext cx="1645920" cy="1371600"/>
+          </a:xfrm>
+          <a:prstGeom prst="rect">
+            <a:avLst/>
+          </a:prstGeom>
+          <a:noFill/>
+        </p:spPr>
+        <p:txBody>
+          <a:bodyPr wrap="square">
+            <a:spAutoFit/>
+          </a:bodyPr>
+          <a:lstStyle/>
+          <a:p>
+            <a:pPr>
+              <a:defRPr sz="1000">
+                <a:solidFill>
+                  <a:srgbClr val="CCCCCC"/>
+                </a:solidFill>
+              </a:defRPr>
+            </a:pPr>
+            <a:r>
+              <a:t>Open-source community contributions grew 10× in one year — production-grade tools, better hardware support, rapidly maturing ecosystem.</a:t>
+            </a:r>
+          </a:p>
+        </p:txBody>
+      </p:sp>
+      <p:sp>
+        <p:nvSpPr>
+          <p:cNvPr id="13" name="Rectangle 12"/>
+          <p:cNvSpPr/>
+          <p:nvPr/>
+        </p:nvSpPr>
+        <p:spPr>
+          <a:xfrm>
+            <a:off x="4480560" y="1280160"/>
+            <a:ext cx="1920240" cy="2560320"/>
+          </a:xfrm>
+          <a:prstGeom prst="rect">
+            <a:avLst/>
+          </a:prstGeom>
+          <a:solidFill>
+            <a:srgbClr val="1A1A1A"/>
+          </a:solidFill>
+          <a:ln>
+            <a:noFill/>
+          </a:ln>
+        </p:spPr>
+        <p:style>
+          <a:lnRef idx="1">
+            <a:schemeClr val="accent1"/>
+          </a:lnRef>
+          <a:fillRef idx="3">
+            <a:schemeClr val="accent1"/>
+          </a:fillRef>
+          <a:effectRef idx="2">
+            <a:schemeClr val="accent1"/>
+          </a:effectRef>
+          <a:fontRef idx="minor">
+            <a:schemeClr val="lt1"/>
+          </a:fontRef>
+        </p:style>
+        <p:txBody>
+          <a:bodyPr rtlCol="0" anchor="ctr"/>
+          <a:lstStyle/>
+          <a:p>
+            <a:pPr algn="ctr"/>
+          </a:p>
+        </p:txBody>
+      </p:sp>
+      <p:sp>
+        <p:nvSpPr>
+          <p:cNvPr id="14" name="Rectangle 13"/>
+          <p:cNvSpPr/>
+          <p:nvPr/>
+        </p:nvSpPr>
+        <p:spPr>
+          <a:xfrm>
+            <a:off x="4480560" y="1280160"/>
+            <a:ext cx="1920240" cy="45720"/>
+          </a:xfrm>
+          <a:prstGeom prst="rect">
+            <a:avLst/>
+          </a:prstGeom>
+          <a:solidFill>
+            <a:srgbClr val="ED1C24"/>
+          </a:solidFill>
+          <a:ln>
+            <a:noFill/>
+          </a:ln>
+        </p:spPr>
+        <p:style>
+          <a:lnRef idx="1">
+            <a:schemeClr val="accent1"/>
+          </a:lnRef>
+          <a:fillRef idx="3">
+            <a:schemeClr val="accent1"/>
+          </a:fillRef>
+          <a:effectRef idx="2">
+            <a:schemeClr val="accent1"/>
+          </a:effectRef>
+          <a:fontRef idx="minor">
+            <a:schemeClr val="lt1"/>
+          </a:fontRef>
+        </p:style>
+        <p:txBody>
+          <a:bodyPr rtlCol="0" anchor="ctr"/>
+          <a:lstStyle/>
+          <a:p>
+            <a:pPr algn="ctr"/>
+          </a:p>
+        </p:txBody>
+      </p:sp>
+      <p:sp>
+        <p:nvSpPr>
+          <p:cNvPr id="15" name="TextBox 14"/>
+          <p:cNvSpPr txBox="1"/>
+          <p:nvPr/>
+        </p:nvSpPr>
+        <p:spPr>
+          <a:xfrm>
+            <a:off x="4617720" y="1417320"/>
+            <a:ext cx="1645920" cy="457200"/>
+          </a:xfrm>
+          <a:prstGeom prst="rect">
+            <a:avLst/>
+          </a:prstGeom>
+          <a:noFill/>
+        </p:spPr>
+        <p:txBody>
+          <a:bodyPr wrap="none">
+            <a:spAutoFit/>
+          </a:bodyPr>
+          <a:lstStyle/>
+          <a:p>
+            <a:pPr>
+              <a:defRPr sz="2800"/>
+            </a:pPr>
+            <a:r>
+              <a:t>⚡</a:t>
+            </a:r>
+          </a:p>
+        </p:txBody>
+      </p:sp>
+      <p:sp>
+        <p:nvSpPr>
+          <p:cNvPr id="16" name="TextBox 15"/>
+          <p:cNvSpPr txBox="1"/>
+          <p:nvPr/>
+        </p:nvSpPr>
+        <p:spPr>
+          <a:xfrm>
+            <a:off x="4617720" y="1828800"/>
+            <a:ext cx="1645920" cy="548640"/>
+          </a:xfrm>
+          <a:prstGeom prst="rect">
+            <a:avLst/>
+          </a:prstGeom>
+          <a:noFill/>
+        </p:spPr>
+        <p:txBody>
+          <a:bodyPr wrap="square">
+            <a:spAutoFit/>
+          </a:bodyPr>
+          <a:lstStyle/>
+          <a:p>
+            <a:pPr>
+              <a:defRPr sz="1200" b="1">
+                <a:solidFill>
+                  <a:srgbClr val="FFFFFF"/>
+                </a:solidFill>
+              </a:defRPr>
+            </a:pPr>
+            <a:r>
+              <a:t>CodeRisk Proves Real-World ROCm Value</a:t>
+            </a:r>
+          </a:p>
+        </p:txBody>
+      </p:sp>
+      <p:sp>
+        <p:nvSpPr>
+          <p:cNvPr id="17" name="TextBox 16"/>
+          <p:cNvSpPr txBox="1"/>
+          <p:nvPr/>
+        </p:nvSpPr>
+        <p:spPr>
+          <a:xfrm>
+            <a:off x="4617720" y="2377440"/>
+            <a:ext cx="1645920" cy="1371600"/>
+          </a:xfrm>
+          <a:prstGeom prst="rect">
+            <a:avLst/>
+          </a:prstGeom>
+          <a:noFill/>
+        </p:spPr>
+        <p:txBody>
+          <a:bodyPr wrap="square">
+            <a:spAutoFit/>
+          </a:bodyPr>
+          <a:lstStyle/>
+          <a:p>
+            <a:pPr>
+              <a:defRPr sz="1000">
+                <a:solidFill>
+                  <a:srgbClr val="CCCCCC"/>
+                </a:solidFill>
+              </a:defRPr>
+            </a:pPr>
+            <a:r>
+              <a:t>Most ROCm benchmarks focus on training. CodeRisk demonstrates ROCm for local AI inference — critical enterprise use case where data cannot leave premises.</a:t>
+            </a:r>
+          </a:p>
+        </p:txBody>
+      </p:sp>
+      <p:sp>
+        <p:nvSpPr>
+          <p:cNvPr id="18" name="Rectangle 17"/>
+          <p:cNvSpPr/>
+          <p:nvPr/>
+        </p:nvSpPr>
+        <p:spPr>
+          <a:xfrm>
+            <a:off x="6537960" y="1280160"/>
+            <a:ext cx="1920240" cy="2560320"/>
+          </a:xfrm>
+          <a:prstGeom prst="rect">
+            <a:avLst/>
+          </a:prstGeom>
+          <a:solidFill>
+            <a:srgbClr val="1A1A1A"/>
+          </a:solidFill>
+          <a:ln>
+            <a:noFill/>
+          </a:ln>
+        </p:spPr>
+        <p:style>
+          <a:lnRef idx="1">
+            <a:schemeClr val="accent1"/>
+          </a:lnRef>
+          <a:fillRef idx="3">
+            <a:schemeClr val="accent1"/>
+          </a:fillRef>
+          <a:effectRef idx="2">
+            <a:schemeClr val="accent1"/>
+          </a:effectRef>
+          <a:fontRef idx="minor">
+            <a:schemeClr val="lt1"/>
+          </a:fontRef>
+        </p:style>
+        <p:txBody>
+          <a:bodyPr rtlCol="0" anchor="ctr"/>
+          <a:lstStyle/>
+          <a:p>
+            <a:pPr algn="ctr"/>
+          </a:p>
+        </p:txBody>
+      </p:sp>
+      <p:sp>
+        <p:nvSpPr>
+          <p:cNvPr id="19" name="Rectangle 18"/>
+          <p:cNvSpPr/>
+          <p:nvPr/>
+        </p:nvSpPr>
+        <p:spPr>
+          <a:xfrm>
+            <a:off x="6537960" y="1280160"/>
+            <a:ext cx="1920240" cy="45720"/>
+          </a:xfrm>
+          <a:prstGeom prst="rect">
+            <a:avLst/>
+          </a:prstGeom>
+          <a:solidFill>
+            <a:srgbClr val="ED1C24"/>
+          </a:solidFill>
+          <a:ln>
+            <a:noFill/>
+          </a:ln>
+        </p:spPr>
+        <p:style>
+          <a:lnRef idx="1">
+            <a:schemeClr val="accent1"/>
+          </a:lnRef>
+          <a:fillRef idx="3">
+            <a:schemeClr val="accent1"/>
+          </a:fillRef>
+          <a:effectRef idx="2">
+            <a:schemeClr val="accent1"/>
+          </a:effectRef>
+          <a:fontRef idx="minor">
+            <a:schemeClr val="lt1"/>
+          </a:fontRef>
+        </p:style>
+        <p:txBody>
+          <a:bodyPr rtlCol="0" anchor="ctr"/>
+          <a:lstStyle/>
+          <a:p>
+            <a:pPr algn="ctr"/>
+          </a:p>
+        </p:txBody>
+      </p:sp>
+      <p:sp>
+        <p:nvSpPr>
+          <p:cNvPr id="20" name="TextBox 19"/>
+          <p:cNvSpPr txBox="1"/>
+          <p:nvPr/>
+        </p:nvSpPr>
+        <p:spPr>
+          <a:xfrm>
+            <a:off x="6675120" y="1417320"/>
+            <a:ext cx="1645920" cy="457200"/>
+          </a:xfrm>
+          <a:prstGeom prst="rect">
+            <a:avLst/>
+          </a:prstGeom>
+          <a:noFill/>
+        </p:spPr>
+        <p:txBody>
+          <a:bodyPr wrap="none">
+            <a:spAutoFit/>
+          </a:bodyPr>
+          <a:lstStyle/>
+          <a:p>
+            <a:pPr>
+              <a:defRPr sz="2800"/>
+            </a:pPr>
+            <a:r>
+              <a:t>🚀</a:t>
+            </a:r>
+          </a:p>
+        </p:txBody>
+      </p:sp>
+      <p:sp>
+        <p:nvSpPr>
+          <p:cNvPr id="21" name="TextBox 20"/>
+          <p:cNvSpPr txBox="1"/>
+          <p:nvPr/>
+        </p:nvSpPr>
+        <p:spPr>
+          <a:xfrm>
+            <a:off x="6675120" y="1828800"/>
+            <a:ext cx="1645920" cy="548640"/>
+          </a:xfrm>
+          <a:prstGeom prst="rect">
+            <a:avLst/>
+          </a:prstGeom>
+          <a:noFill/>
+        </p:spPr>
+        <p:txBody>
+          <a:bodyPr wrap="square">
+            <a:spAutoFit/>
+          </a:bodyPr>
+          <a:lstStyle/>
+          <a:p>
+            <a:pPr>
+              <a:defRPr sz="1200" b="1">
+                <a:solidFill>
+                  <a:srgbClr val="FFFFFF"/>
+                </a:solidFill>
+              </a:defRPr>
+            </a:pPr>
+            <a:r>
+              <a:t>From Benchmark to Production</a:t>
+            </a:r>
+          </a:p>
+        </p:txBody>
+      </p:sp>
+      <p:sp>
+        <p:nvSpPr>
+          <p:cNvPr id="22" name="TextBox 21"/>
+          <p:cNvSpPr txBox="1"/>
+          <p:nvPr/>
+        </p:nvSpPr>
+        <p:spPr>
+          <a:xfrm>
+            <a:off x="6675120" y="2377440"/>
+            <a:ext cx="1645920" cy="1371600"/>
+          </a:xfrm>
+          <a:prstGeom prst="rect">
+            <a:avLst/>
+          </a:prstGeom>
+          <a:noFill/>
+        </p:spPr>
+        <p:txBody>
+          <a:bodyPr wrap="square">
+            <a:spAutoFit/>
+          </a:bodyPr>
+          <a:lstStyle/>
+          <a:p>
+            <a:pPr>
+              <a:defRPr sz="1000">
+                <a:solidFill>
+                  <a:srgbClr val="CCCCCC"/>
+                </a:solidFill>
+              </a:defRPr>
+            </a:pPr>
+            <a:r>
+              <a:t>4-agent pipeline on single W7900 GPU via ROCm/HIP. 29.4 t/s with 32B model. ROCm is ready for real-time production applications.</a:t>
+            </a:r>
+          </a:p>
+        </p:txBody>
+      </p:sp>
+      <p:sp>
+        <p:nvSpPr>
+          <p:cNvPr id="23" name="Rectangle 22"/>
+          <p:cNvSpPr/>
+          <p:nvPr/>
+        </p:nvSpPr>
+        <p:spPr>
+          <a:xfrm>
+            <a:off x="365760" y="4114800"/>
+            <a:ext cx="8412480" cy="640080"/>
+          </a:xfrm>
+          <a:prstGeom prst="rect">
+            <a:avLst/>
+          </a:prstGeom>
+          <a:solidFill>
+            <a:srgbClr val="1A1A1A"/>
+          </a:solidFill>
+          <a:ln w="25400">
+            <a:solidFill>
+              <a:srgbClr val="ED1C24"/>
+            </a:solidFill>
+          </a:ln>
+        </p:spPr>
+        <p:style>
+          <a:lnRef idx="1">
+            <a:schemeClr val="accent1"/>
+          </a:lnRef>
+          <a:fillRef idx="3">
+            <a:schemeClr val="accent1"/>
+          </a:fillRef>
+          <a:effectRef idx="2">
+            <a:schemeClr val="accent1"/>
+          </a:effectRef>
+          <a:fontRef idx="minor">
+            <a:schemeClr val="lt1"/>
+          </a:fontRef>
+        </p:style>
+        <p:txBody>
+          <a:bodyPr rtlCol="0" anchor="ctr" wrap="square"/>
+          <a:lstStyle/>
+          <a:p>
+            <a:pPr algn="ctr">
+              <a:defRPr sz="1400" i="1">
+                <a:solidFill>
+                  <a:srgbClr val="FFFFFF"/>
+                </a:solidFill>
+              </a:defRPr>
+            </a:pPr>
+            <a:r>
+              <a:t>CodeRisk Agent is proof that ROCm can power production-grade local AI workloads — not just training benchmarks.</a:t>
+            </a:r>
+          </a:p>
+        </p:txBody>
+      </p:sp>
+    </p:spTree>
+  </p:cSld>
+  <p:clrMapOvr>
+    <a:masterClrMapping/>
+  </p:clrMapOvr>
+</p:sld>
+</file>
+
+<file path=ppt/slides/slide11.xml><?xml version="1.0" encoding="utf-8"?>
+<p:sld xmlns:a="http://schemas.openxmlformats.org/drawingml/2006/main" xmlns:p="http://schemas.openxmlformats.org/presentationml/2006/main" xmlns:r="http://schemas.openxmlformats.org/officeDocument/2006/relationships">
+  <p:cSld>
+    <p:bg>
+      <p:bgPr>
+        <a:solidFill>
+          <a:srgbClr val="0D0D0D"/>
+        </a:solidFill>
+        <a:effectLst/>
+      </p:bgPr>
+    </p:bg>
+    <p:spTree>
+      <p:nvGrpSpPr>
+        <p:cNvPr id="1" name=""/>
+        <p:cNvGrpSpPr/>
+        <p:nvPr/>
+      </p:nvGrpSpPr>
+      <p:grpSpPr/>
+      <p:sp>
+        <p:nvSpPr>
+          <p:cNvPr id="2" name="TextBox 1"/>
+          <p:cNvSpPr txBox="1"/>
+          <p:nvPr/>
+        </p:nvSpPr>
+        <p:spPr>
+          <a:xfrm>
+            <a:off x="457200" y="274320"/>
+            <a:ext cx="8229600" cy="731520"/>
+          </a:xfrm>
+          <a:prstGeom prst="rect">
+            <a:avLst/>
+          </a:prstGeom>
+          <a:noFill/>
+        </p:spPr>
+        <p:txBody>
+          <a:bodyPr wrap="none">
+            <a:spAutoFit/>
+          </a:bodyPr>
+          <a:lstStyle/>
+          <a:p>
+            <a:pPr algn="ctr">
+              <a:defRPr sz="2800" b="1">
+                <a:solidFill>
+                  <a:srgbClr val="ED1C24"/>
+                </a:solidFill>
+              </a:defRPr>
+            </a:pPr>
+            <a:r>
+              <a:t>ROCm Differentiation — Why Open Matters</a:t>
+            </a:r>
+          </a:p>
+        </p:txBody>
+      </p:sp>
+      <p:sp>
+        <p:nvSpPr>
+          <p:cNvPr id="3" name="Rectangle 2"/>
+          <p:cNvSpPr/>
+          <p:nvPr/>
+        </p:nvSpPr>
+        <p:spPr>
+          <a:xfrm>
+            <a:off x="457200" y="1280160"/>
+            <a:ext cx="54864" cy="822960"/>
+          </a:xfrm>
+          <a:prstGeom prst="rect">
+            <a:avLst/>
+          </a:prstGeom>
+          <a:solidFill>
+            <a:srgbClr val="ED1C24"/>
+          </a:solidFill>
+          <a:ln>
+            <a:noFill/>
+          </a:ln>
+        </p:spPr>
+        <p:style>
+          <a:lnRef idx="1">
+            <a:schemeClr val="accent1"/>
+          </a:lnRef>
+          <a:fillRef idx="3">
+            <a:schemeClr val="accent1"/>
+          </a:fillRef>
+          <a:effectRef idx="2">
+            <a:schemeClr val="accent1"/>
+          </a:effectRef>
+          <a:fontRef idx="minor">
+            <a:schemeClr val="lt1"/>
+          </a:fontRef>
+        </p:style>
+        <p:txBody>
+          <a:bodyPr rtlCol="0" anchor="ctr"/>
+          <a:lstStyle/>
+          <a:p>
+            <a:pPr algn="ctr"/>
+          </a:p>
+        </p:txBody>
+      </p:sp>
+      <p:sp>
+        <p:nvSpPr>
+          <p:cNvPr id="4" name="TextBox 3"/>
+          <p:cNvSpPr txBox="1"/>
+          <p:nvPr/>
+        </p:nvSpPr>
+        <p:spPr>
+          <a:xfrm>
+            <a:off x="640080" y="1280160"/>
+            <a:ext cx="7315200" cy="365760"/>
+          </a:xfrm>
+          <a:prstGeom prst="rect">
+            <a:avLst/>
+          </a:prstGeom>
+          <a:noFill/>
+        </p:spPr>
+        <p:txBody>
+          <a:bodyPr wrap="none">
+            <a:spAutoFit/>
+          </a:bodyPr>
+          <a:lstStyle/>
+          <a:p>
+            <a:pPr>
+              <a:defRPr sz="1600" b="1">
+                <a:solidFill>
+                  <a:srgbClr val="FFFFFF"/>
+                </a:solidFill>
+              </a:defRPr>
+            </a:pPr>
+            <a:r>
+              <a:t>🟥  Open-Source Customization</a:t>
+            </a:r>
+          </a:p>
+        </p:txBody>
+      </p:sp>
+      <p:sp>
+        <p:nvSpPr>
+          <p:cNvPr id="5" name="TextBox 4"/>
+          <p:cNvSpPr txBox="1"/>
+          <p:nvPr/>
+        </p:nvSpPr>
+        <p:spPr>
+          <a:xfrm>
+            <a:off x="640080" y="1645920"/>
+            <a:ext cx="7315200" cy="457200"/>
+          </a:xfrm>
+          <a:prstGeom prst="rect">
+            <a:avLst/>
+          </a:prstGeom>
+          <a:noFill/>
+        </p:spPr>
+        <p:txBody>
+          <a:bodyPr wrap="square">
+            <a:spAutoFit/>
+          </a:bodyPr>
+          <a:lstStyle/>
+          <a:p>
+            <a:pPr>
+              <a:defRPr sz="1200">
+                <a:solidFill>
+                  <a:srgbClr val="CCCCCC"/>
+                </a:solidFill>
+              </a:defRPr>
+            </a:pPr>
+            <a:r>
+              <a:t>Custom HIP kernels directly modify low-level behavior. CUDA's closed ecosystem cannot match this granularity of optimization.</a:t>
+            </a:r>
+          </a:p>
+        </p:txBody>
+      </p:sp>
+      <p:sp>
+        <p:nvSpPr>
+          <p:cNvPr id="6" name="Rectangle 5"/>
+          <p:cNvSpPr/>
+          <p:nvPr/>
+        </p:nvSpPr>
+        <p:spPr>
+          <a:xfrm>
+            <a:off x="457200" y="2286000"/>
+            <a:ext cx="54864" cy="822960"/>
+          </a:xfrm>
+          <a:prstGeom prst="rect">
+            <a:avLst/>
+          </a:prstGeom>
+          <a:solidFill>
+            <a:srgbClr val="ED1C24"/>
+          </a:solidFill>
+          <a:ln>
+            <a:noFill/>
+          </a:ln>
+        </p:spPr>
+        <p:style>
+          <a:lnRef idx="1">
+            <a:schemeClr val="accent1"/>
+          </a:lnRef>
+          <a:fillRef idx="3">
+            <a:schemeClr val="accent1"/>
+          </a:fillRef>
+          <a:effectRef idx="2">
+            <a:schemeClr val="accent1"/>
+          </a:effectRef>
+          <a:fontRef idx="minor">
+            <a:schemeClr val="lt1"/>
+          </a:fontRef>
+        </p:style>
+        <p:txBody>
+          <a:bodyPr rtlCol="0" anchor="ctr"/>
+          <a:lstStyle/>
+          <a:p>
+            <a:pPr algn="ctr"/>
+          </a:p>
+        </p:txBody>
+      </p:sp>
+      <p:sp>
+        <p:nvSpPr>
+          <p:cNvPr id="7" name="TextBox 6"/>
+          <p:cNvSpPr txBox="1"/>
+          <p:nvPr/>
+        </p:nvSpPr>
+        <p:spPr>
+          <a:xfrm>
+            <a:off x="640080" y="2286000"/>
+            <a:ext cx="7315200" cy="365760"/>
+          </a:xfrm>
+          <a:prstGeom prst="rect">
+            <a:avLst/>
+          </a:prstGeom>
+          <a:noFill/>
+        </p:spPr>
+        <p:txBody>
+          <a:bodyPr wrap="none">
+            <a:spAutoFit/>
+          </a:bodyPr>
+          <a:lstStyle/>
+          <a:p>
+            <a:pPr>
+              <a:defRPr sz="1600" b="1">
+                <a:solidFill>
+                  <a:srgbClr val="FFFFFF"/>
+                </a:solidFill>
+              </a:defRPr>
+            </a:pPr>
+            <a:r>
+              <a:t>🟥  Hardware Cost Advantage</a:t>
+            </a:r>
+          </a:p>
+        </p:txBody>
+      </p:sp>
+      <p:sp>
+        <p:nvSpPr>
+          <p:cNvPr id="8" name="TextBox 7"/>
+          <p:cNvSpPr txBox="1"/>
+          <p:nvPr/>
+        </p:nvSpPr>
+        <p:spPr>
+          <a:xfrm>
+            <a:off x="640080" y="2651760"/>
+            <a:ext cx="7315200" cy="457200"/>
+          </a:xfrm>
+          <a:prstGeom prst="rect">
+            <a:avLst/>
+          </a:prstGeom>
+          <a:noFill/>
+        </p:spPr>
+        <p:txBody>
+          <a:bodyPr wrap="square">
+            <a:spAutoFit/>
+          </a:bodyPr>
+          <a:lstStyle/>
+          <a:p>
+            <a:pPr>
+              <a:defRPr sz="1200">
+                <a:solidFill>
+                  <a:srgbClr val="CCCCCC"/>
+                </a:solidFill>
+              </a:defRPr>
+            </a:pPr>
+            <a:r>
+              <a:t>W7900 ($3,999) vs A100 ($10,000+). Enterprise local deployment barrier significantly reduced.</a:t>
+            </a:r>
+          </a:p>
+        </p:txBody>
+      </p:sp>
+      <p:sp>
+        <p:nvSpPr>
+          <p:cNvPr id="9" name="Rectangle 8"/>
+          <p:cNvSpPr/>
+          <p:nvPr/>
+        </p:nvSpPr>
+        <p:spPr>
+          <a:xfrm>
+            <a:off x="457200" y="3291840"/>
+            <a:ext cx="54864" cy="822960"/>
+          </a:xfrm>
+          <a:prstGeom prst="rect">
+            <a:avLst/>
+          </a:prstGeom>
+          <a:solidFill>
+            <a:srgbClr val="ED1C24"/>
+          </a:solidFill>
+          <a:ln>
+            <a:noFill/>
+          </a:ln>
+        </p:spPr>
+        <p:style>
+          <a:lnRef idx="1">
+            <a:schemeClr val="accent1"/>
+          </a:lnRef>
+          <a:fillRef idx="3">
+            <a:schemeClr val="accent1"/>
+          </a:fillRef>
+          <a:effectRef idx="2">
+            <a:schemeClr val="accent1"/>
+          </a:effectRef>
+          <a:fontRef idx="minor">
+            <a:schemeClr val="lt1"/>
+          </a:fontRef>
+        </p:style>
+        <p:txBody>
+          <a:bodyPr rtlCol="0" anchor="ctr"/>
+          <a:lstStyle/>
+          <a:p>
+            <a:pPr algn="ctr"/>
+          </a:p>
+        </p:txBody>
+      </p:sp>
+      <p:sp>
+        <p:nvSpPr>
+          <p:cNvPr id="10" name="TextBox 9"/>
+          <p:cNvSpPr txBox="1"/>
+          <p:nvPr/>
+        </p:nvSpPr>
+        <p:spPr>
+          <a:xfrm>
+            <a:off x="640080" y="3291840"/>
+            <a:ext cx="7315200" cy="365760"/>
+          </a:xfrm>
+          <a:prstGeom prst="rect">
+            <a:avLst/>
+          </a:prstGeom>
+          <a:noFill/>
+        </p:spPr>
+        <p:txBody>
+          <a:bodyPr wrap="none">
+            <a:spAutoFit/>
+          </a:bodyPr>
+          <a:lstStyle/>
+          <a:p>
+            <a:pPr>
+              <a:defRPr sz="1600" b="1">
+                <a:solidFill>
+                  <a:srgbClr val="FFFFFF"/>
+                </a:solidFill>
+              </a:defRPr>
+            </a:pPr>
+            <a:r>
+              <a:t>🟥  No Vendor Lock-in</a:t>
+            </a:r>
+          </a:p>
+        </p:txBody>
+      </p:sp>
+      <p:sp>
+        <p:nvSpPr>
+          <p:cNvPr id="11" name="TextBox 10"/>
+          <p:cNvSpPr txBox="1"/>
+          <p:nvPr/>
+        </p:nvSpPr>
+        <p:spPr>
+          <a:xfrm>
+            <a:off x="640080" y="3657600"/>
+            <a:ext cx="7315200" cy="457200"/>
+          </a:xfrm>
+          <a:prstGeom prst="rect">
+            <a:avLst/>
+          </a:prstGeom>
+          <a:noFill/>
+        </p:spPr>
+        <p:txBody>
+          <a:bodyPr wrap="square">
+            <a:spAutoFit/>
+          </a:bodyPr>
+          <a:lstStyle/>
+          <a:p>
+            <a:pPr>
+              <a:defRPr sz="1200">
+                <a:solidFill>
+                  <a:srgbClr val="CCCCCC"/>
+                </a:solidFill>
+              </a:defRPr>
+            </a:pPr>
+            <a:r>
+              <a:t>No dependency on NVIDIA licensing strategy changes. ROCm's open-source license ensures long-term availability.</a:t>
+            </a:r>
+          </a:p>
+        </p:txBody>
+      </p:sp>
+      <p:sp>
+        <p:nvSpPr>
+          <p:cNvPr id="12" name="Rectangle 11"/>
+          <p:cNvSpPr/>
+          <p:nvPr/>
+        </p:nvSpPr>
+        <p:spPr>
+          <a:xfrm>
+            <a:off x="457200" y="4297680"/>
+            <a:ext cx="54864" cy="822960"/>
+          </a:xfrm>
+          <a:prstGeom prst="rect">
+            <a:avLst/>
+          </a:prstGeom>
+          <a:solidFill>
+            <a:srgbClr val="ED1C24"/>
+          </a:solidFill>
+          <a:ln>
+            <a:noFill/>
+          </a:ln>
+        </p:spPr>
+        <p:style>
+          <a:lnRef idx="1">
+            <a:schemeClr val="accent1"/>
+          </a:lnRef>
+          <a:fillRef idx="3">
+            <a:schemeClr val="accent1"/>
+          </a:fillRef>
+          <a:effectRef idx="2">
+            <a:schemeClr val="accent1"/>
+          </a:effectRef>
+          <a:fontRef idx="minor">
+            <a:schemeClr val="lt1"/>
+          </a:fontRef>
+        </p:style>
+        <p:txBody>
+          <a:bodyPr rtlCol="0" anchor="ctr"/>
+          <a:lstStyle/>
+          <a:p>
+            <a:pPr algn="ctr"/>
+          </a:p>
+        </p:txBody>
+      </p:sp>
+      <p:sp>
+        <p:nvSpPr>
+          <p:cNvPr id="13" name="TextBox 12"/>
+          <p:cNvSpPr txBox="1"/>
+          <p:nvPr/>
+        </p:nvSpPr>
+        <p:spPr>
+          <a:xfrm>
+            <a:off x="640080" y="4297680"/>
+            <a:ext cx="7315200" cy="365760"/>
+          </a:xfrm>
+          <a:prstGeom prst="rect">
+            <a:avLst/>
+          </a:prstGeom>
+          <a:noFill/>
+        </p:spPr>
+        <p:txBody>
+          <a:bodyPr wrap="none">
+            <a:spAutoFit/>
+          </a:bodyPr>
+          <a:lstStyle/>
+          <a:p>
+            <a:pPr>
+              <a:defRPr sz="1600" b="1">
+                <a:solidFill>
+                  <a:srgbClr val="FFFFFF"/>
+                </a:solidFill>
+              </a:defRPr>
+            </a:pPr>
+            <a:r>
+              <a:t>🟥  10× Community Growth = Ecosystem Certainty</a:t>
+            </a:r>
+          </a:p>
+        </p:txBody>
+      </p:sp>
+      <p:sp>
+        <p:nvSpPr>
+          <p:cNvPr id="14" name="TextBox 13"/>
+          <p:cNvSpPr txBox="1"/>
+          <p:nvPr/>
+        </p:nvSpPr>
+        <p:spPr>
+          <a:xfrm>
+            <a:off x="640080" y="4663440"/>
+            <a:ext cx="7315200" cy="457200"/>
+          </a:xfrm>
+          <a:prstGeom prst="rect">
+            <a:avLst/>
+          </a:prstGeom>
+          <a:noFill/>
+        </p:spPr>
+        <p:txBody>
+          <a:bodyPr wrap="square">
+            <a:spAutoFit/>
+          </a:bodyPr>
+          <a:lstStyle/>
+          <a:p>
+            <a:pPr>
+              <a:defRPr sz="1200">
+                <a:solidFill>
+                  <a:srgbClr val="CCCCCC"/>
+                </a:solidFill>
+              </a:defRPr>
+            </a:pPr>
+            <a:r>
+              <a:t>Toolchain, documentation, community support maturing rapidly. Investment risk lower than 2 years ago.</a:t>
+            </a:r>
+          </a:p>
+        </p:txBody>
+      </p:sp>
+      <p:sp>
+        <p:nvSpPr>
+          <p:cNvPr id="15" name="TextBox 14"/>
+          <p:cNvSpPr txBox="1"/>
+          <p:nvPr/>
+        </p:nvSpPr>
+        <p:spPr>
+          <a:xfrm>
+            <a:off x="457200" y="4754880"/>
+            <a:ext cx="8229600" cy="457200"/>
+          </a:xfrm>
+          <a:prstGeom prst="rect">
+            <a:avLst/>
+          </a:prstGeom>
+          <a:noFill/>
+        </p:spPr>
+        <p:txBody>
+          <a:bodyPr wrap="none">
+            <a:spAutoFit/>
+          </a:bodyPr>
+          <a:lstStyle/>
+          <a:p>
+            <a:pPr algn="ctr">
+              <a:defRPr sz="1300" i="1">
+                <a:solidFill>
+                  <a:srgbClr val="ED1C24"/>
+                </a:solidFill>
+              </a:defRPr>
+            </a:pPr>
+            <a:r>
+              <a:t>"Choosing ROCm is not settling for less — it's a strategic decision for open, cost-effective AI."</a:t>
+            </a:r>
+          </a:p>
+        </p:txBody>
+      </p:sp>
+    </p:spTree>
+  </p:cSld>
+  <p:clrMapOvr>
+    <a:masterClrMapping/>
+  </p:clrMapOvr>
+</p:sld>
+</file>
+
 <file path=ppt/slides/slide2.xml><?xml version="1.0" encoding="utf-8"?>
 <p:sld xmlns:a="http://schemas.openxmlformats.org/drawingml/2006/main" xmlns:p="http://schemas.openxmlformats.org/presentationml/2006/main" xmlns:r="http://schemas.openxmlformats.org/officeDocument/2006/relationships">
   <p:cSld>
@@ -5991,7 +7404,7 @@
               </a:defRPr>
             </a:pPr>
             <a:r>
-              <a:t>Token Gen: 105 t/s (15.4× vs CPU)</a:t>
+              <a:t>Token Gen: 29.4 t/s (4.3× vs CPU)</a:t>
             </a:r>
           </a:p>
           <a:p>
@@ -8204,7 +9617,7 @@
               </a:defRPr>
             </a:pPr>
             <a:r>
-              <a:t>15.4×</a:t>
+              <a:t>4.3×</a:t>
             </a:r>
           </a:p>
         </p:txBody>

</xml_diff>

<commit_message>
fix: PPT Page 5 - restore 7B/32B comparison in performance data
- Token Gen: 29.4 t/s (32B, 4.3×) / 105 t/s (7B, 15.4×)
- Prompt Proc: 264.8 t/s (32B) / 667 t/s (7B)
- All pages verified: no isolated old data
</commit_message>
<xml_diff>
--- a/docs/CodeRisk_Agent_Presentation.pptx
+++ b/docs/CodeRisk_Agent_Presentation.pptx
@@ -7404,7 +7404,7 @@
               </a:defRPr>
             </a:pPr>
             <a:r>
-              <a:t>Token Gen: 29.4 t/s (4.3× vs CPU)</a:t>
+              <a:t>Token Gen: 29.4 t/s (32B, 4.3× vs CPU) / 105 t/s (7B, 15.4×)</a:t>
             </a:r>
           </a:p>
           <a:p>
@@ -7419,7 +7419,7 @@
               </a:defRPr>
             </a:pPr>
             <a:r>
-              <a:t>Prompt Proc: 667 t/s</a:t>
+              <a:t>Prompt Proc: 264.8 (32B) / 667 (7B) t/s</a:t>
             </a:r>
           </a:p>
           <a:p>

</xml_diff>